<commit_message>
Update Stage 2 framing in project notes and Oct 7 slides
</commit_message>
<xml_diff>
--- a/Notes/Mina_Meeting_Slides_2026-10-07.pptx
+++ b/Notes/Mina_Meeting_Slides_2026-10-07.pptx
@@ -17,6 +17,7 @@
     <p:sldId id="265" r:id="rId11"/>
     <p:sldId id="266" r:id="rId12"/>
     <p:sldId id="267" r:id="rId13"/>
+    <p:sldId id="270" r:id="rId21"/>
     <p:sldId id="268" r:id="rId14"/>
     <p:sldId id="269" r:id="rId15"/>
   </p:sldIdLst>
@@ -1150,7 +1151,7 @@
           <a:p>
             <a:r>
               <a:rPr lang="en-US" dirty="0"/>
-              <a:t>Stage 2 is a decision, recorded in the Overleaf and the project notes, not a notebook. We define two encoders as aligned to the extent that their representations of the same inputs agree on held-out examples after the composition control, and we report that separately from complementarity, the concatenation gain, because Stage 1 shows the two need not coincide. In the decision tree the pairs fall in the mixed branch, so each pairing is decided on its own terms. The proposal is no alignment loss in the first fusion models, a shared codon grid only on the stability data, one encoder per redundant family, and codon-level RNA with protein as the first pairing. Any code this calls for is built and tested in Stage 3.</a:t>
+              <a:t>Stage 2 is a decision, recorded in the Overleaf and the project notes, not a notebook, and it runs no experiments. We impose only the positional alignment the biology gives us: the codon grid on the stability data, and cross-attention on GTEx, where no grid exists. The first fusion models train on the prediction loss alone, because a contrastive alignment term would mostly push encoders to agree on composition and could erase what only one modality carries, such as codon choice. CaLM with a protein encoder is the one pair that stays aligned after the composition control, so it gets the one ablation, with and without an alignment loss. We start with the pairings Stage 1 favors, keep one ESM-2 model per experiment, and report each pair's alignment before and after the control beside its fusion gain, which tests whether Stage 1 predicts where fusion helps.</a:t>
             </a:r>
             <a:endParaRPr lang="en-US" dirty="0"/>
           </a:p>
@@ -1271,6 +1272,94 @@
     <p:extLst>
       <p:ext uri="{BB962C8B-B14F-4D97-AF65-F5344CB8AC3E}">
         <p14:creationId xmlns:p14="http://schemas.microsoft.com/office/powerpoint/2010/main" val="1024086991"/>
+      </p:ext>
+    </p:extLst>
+  </p:cSld>
+  <p:clrMapOvr>
+    <a:masterClrMapping/>
+  </p:clrMapOvr>
+</p:notes>
+</file>
+
+<file path=ppt/notesSlides/notesSlide15.xml><?xml version="1.0" encoding="utf-8"?>
+<p:notes xmlns:a="http://schemas.openxmlformats.org/drawingml/2006/main" xmlns:r="http://schemas.openxmlformats.org/officeDocument/2006/relationships" xmlns:p="http://schemas.openxmlformats.org/presentationml/2006/main">
+  <p:cSld>
+    <p:spTree>
+      <p:nvGrpSpPr>
+        <p:cNvPr id="1" name=""/>
+        <p:cNvGrpSpPr/>
+        <p:nvPr/>
+      </p:nvGrpSpPr>
+      <p:grpSpPr>
+        <a:xfrm>
+          <a:off x="0" y="0"/>
+          <a:ext cx="0" cy="0"/>
+          <a:chOff x="0" y="0"/>
+          <a:chExt cx="0" cy="0"/>
+        </a:xfrm>
+      </p:grpSpPr>
+      <p:sp>
+        <p:nvSpPr>
+          <p:cNvPr id="2" name="Slide Image Placeholder 1"/>
+          <p:cNvSpPr>
+            <a:spLocks noGrp="1" noRot="1" noChangeAspect="1"/>
+          </p:cNvSpPr>
+          <p:nvPr>
+            <p:ph type="sldImg"/>
+          </p:nvPr>
+        </p:nvSpPr>
+        <p:spPr/>
+      </p:sp>
+      <p:sp>
+        <p:nvSpPr>
+          <p:cNvPr id="3" name="Notes Placeholder 2"/>
+          <p:cNvSpPr>
+            <a:spLocks noGrp="1"/>
+          </p:cNvSpPr>
+          <p:nvPr>
+            <p:ph type="body" idx="1"/>
+          </p:nvPr>
+        </p:nvSpPr>
+        <p:spPr/>
+        <p:txBody>
+          <a:bodyPr/>
+          <a:lstStyle/>
+          <a:p>
+            <a:r>
+              <a:rPr lang="en-US" dirty="0"/>
+              <a:t>Alignment has two meanings here. Positional alignment means step t in every input is the same place in the gene, the way video frame t and audio window t are the same moment. Biology gives us this on the stability data, because each codon maps to exactly one amino acid, so we can resample every encoder's tokens onto one codon grid, which is what Coupled Mamba needs. On GTEx there is no such mapping between the promoter window, the transcript, and the protein. Representational alignment means two encoders see the same genes as similar. Stage 1 measured it, and most of the raw agreement turned out to be letter, codon, and amino-acid counts. After removing those, only the ESM-2 models, RNA-FM with RiNALMo, and CaLM with the protein encoders still agree. Alignment never predicted which sequences were predicted well, and some of the most useful pairings barely align. So for us alignment is something we measure and report, not something we train toward.</a:t>
+            </a:r>
+            <a:endParaRPr lang="en-US" dirty="0"/>
+          </a:p>
+        </p:txBody>
+      </p:sp>
+      <p:sp>
+        <p:nvSpPr>
+          <p:cNvPr id="4" name="Slide Number Placeholder 3"/>
+          <p:cNvSpPr>
+            <a:spLocks noGrp="1"/>
+          </p:cNvSpPr>
+          <p:nvPr>
+            <p:ph type="sldNum" sz="quarter" idx="10"/>
+          </p:nvPr>
+        </p:nvSpPr>
+        <p:spPr/>
+        <p:txBody>
+          <a:bodyPr/>
+          <a:lstStyle/>
+          <a:p>
+            <a:fld id="{F7021451-1387-4CA6-816F-3879F97B5CBC}" type="slidenum">
+              <a:rPr lang="en-US"/>
+              <a:t>13</a:t>
+            </a:fld>
+            <a:endParaRPr lang="en-US"/>
+          </a:p>
+        </p:txBody>
+      </p:sp>
+    </p:spTree>
+    <p:extLst>
+      <p:ext uri="{BB962C8B-B14F-4D97-AF65-F5344CB8AC3E}">
+        <p14:creationId xmlns:p14="http://schemas.microsoft.com/office/powerpoint/2010/main" val="1024086992"/>
       </p:ext>
     </p:extLst>
   </p:cSld>
@@ -10241,7 +10330,7 @@
       </p:grpSpPr>
       <p:sp>
         <p:nvSpPr>
-          <p:cNvPr id="2" name="Text 0"/>
+          <p:cNvPr id="2" name="Eyebrow"/>
           <p:cNvSpPr txBox="1"/>
           <p:nvPr/>
         </p:nvSpPr>
@@ -10272,7 +10361,7 @@
                 <a:ea typeface="Calibri" pitchFamily="34" charset="-122"/>
                 <a:cs typeface="Calibri" pitchFamily="34" charset="-120"/>
               </a:rPr>
-              <a:t>STAGE 2 · DEFINING ALIGNMENT</a:t>
+              <a:t>STAGE 2 · DECISION</a:t>
             </a:r>
             <a:endParaRPr lang="en-US" sz="1300" dirty="0"/>
           </a:p>
@@ -10280,7 +10369,7 @@
       </p:sp>
       <p:sp>
         <p:nvSpPr>
-          <p:cNvPr id="3" name="Text 1"/>
+          <p:cNvPr id="3" name="Title"/>
           <p:cNvSpPr txBox="1"/>
           <p:nvPr/>
         </p:nvSpPr>
@@ -10311,7 +10400,7 @@
                 <a:ea typeface="Cambria" pitchFamily="34" charset="-122"/>
                 <a:cs typeface="Cambria" pitchFamily="34" charset="-120"/>
               </a:rPr>
-              <a:t>Proposed decision: no explicit alignment loss</a:t>
+              <a:t>Proposed decision: go straight to fusion</a:t>
             </a:r>
             <a:endParaRPr lang="en-US" sz="3200" dirty="0"/>
           </a:p>
@@ -10319,7 +10408,7 @@
       </p:sp>
       <p:sp>
         <p:nvSpPr>
-          <p:cNvPr id="4" name="Shape 2"/>
+          <p:cNvPr id="4" name="Card 1"/>
           <p:cNvSpPr/>
           <p:nvPr/>
         </p:nvSpPr>
@@ -10346,7 +10435,7 @@
       </p:sp>
       <p:sp>
         <p:nvSpPr>
-          <p:cNvPr id="5" name="Text 3"/>
+          <p:cNvPr id="5" name="Card 1 title"/>
           <p:cNvSpPr txBox="1"/>
           <p:nvPr/>
         </p:nvSpPr>
@@ -10377,7 +10466,7 @@
                 <a:ea typeface="Calibri" pitchFamily="34" charset="-122"/>
                 <a:cs typeface="Calibri" pitchFamily="34" charset="-120"/>
               </a:rPr>
-              <a:t>No explicit alignment loss</a:t>
+              <a:t>Impose positional alignment only</a:t>
             </a:r>
             <a:endParaRPr lang="en-US" sz="1600" dirty="0"/>
           </a:p>
@@ -10385,14 +10474,14 @@
       </p:sp>
       <p:sp>
         <p:nvSpPr>
-          <p:cNvPr id="6" name="Text 4"/>
+          <p:cNvPr id="6" name="Card 1 body"/>
           <p:cNvSpPr txBox="1"/>
           <p:nvPr/>
         </p:nvSpPr>
         <p:spPr>
           <a:xfrm>
-            <a:off x="960120" y="2258568"/>
-            <a:ext cx="4722876" cy="1188720"/>
+            <a:off x="960120" y="2295144"/>
+            <a:ext cx="4722876" cy="1106424"/>
           </a:xfrm>
           <a:prstGeom prst="rect">
             <a:avLst/>
@@ -10416,7 +10505,7 @@
                 <a:ea typeface="Calibri" pitchFamily="34" charset="-122"/>
                 <a:cs typeface="Calibri" pitchFamily="34" charset="-120"/>
               </a:rPr>
-              <a:t>Per-sequence alignment never tracks error (66 pairs, both datasets), and most cross-modal agreement is composition. Fusion learns the interaction; an alignment-loss ablation runs on CaLM with protein, the one cross-modal pairing whose agreement survives the control.</a:t>
+              <a:t>Stability: resample DNA, RNA, and protein tokens to one codon grid, the step grid Coupled Mamba needs. GTEx: no grid exists, so cross-attention or pooled fusion.</a:t>
             </a:r>
             <a:endParaRPr lang="en-US" sz="1500" dirty="0"/>
           </a:p>
@@ -10424,7 +10513,7 @@
       </p:sp>
       <p:sp>
         <p:nvSpPr>
-          <p:cNvPr id="7" name="Shape 5"/>
+          <p:cNvPr id="7" name="Card 2"/>
           <p:cNvSpPr/>
           <p:nvPr/>
         </p:nvSpPr>
@@ -10451,7 +10540,7 @@
       </p:sp>
       <p:sp>
         <p:nvSpPr>
-          <p:cNvPr id="8" name="Text 6"/>
+          <p:cNvPr id="8" name="Card 2 title"/>
           <p:cNvSpPr txBox="1"/>
           <p:nvPr/>
         </p:nvSpPr>
@@ -10482,7 +10571,7 @@
                 <a:ea typeface="Calibri" pitchFamily="34" charset="-122"/>
                 <a:cs typeface="Calibri" pitchFamily="34" charset="-120"/>
               </a:rPr>
-              <a:t>Codon grid only where biology supplies it</a:t>
+              <a:t>No alignment loss by default</a:t>
             </a:r>
             <a:endParaRPr lang="en-US" sz="1600" dirty="0"/>
           </a:p>
@@ -10490,14 +10579,14 @@
       </p:sp>
       <p:sp>
         <p:nvSpPr>
-          <p:cNvPr id="9" name="Text 7"/>
+          <p:cNvPr id="9" name="Card 2 body"/>
           <p:cNvSpPr txBox="1"/>
           <p:nvPr/>
         </p:nvSpPr>
         <p:spPr>
           <a:xfrm>
-            <a:off x="6505956" y="2258568"/>
-            <a:ext cx="4722876" cy="1188720"/>
+            <a:off x="6505956" y="2295144"/>
+            <a:ext cx="4722876" cy="1106424"/>
           </a:xfrm>
           <a:prstGeom prst="rect">
             <a:avLst/>
@@ -10521,7 +10610,7 @@
                 <a:ea typeface="Calibri" pitchFamily="34" charset="-122"/>
                 <a:cs typeface="Calibri" pitchFamily="34" charset="-120"/>
               </a:rPr>
-              <a:t>Stability: DNA, RNA, and protein tokens share one codon grid, the step grid Coupled Mamba needs. GTEx: no position-by-position correspondence, so cross-attention or pooled fusion.</a:t>
+              <a:t>Train on the prediction loss alone. One ablation: CaLM with a protein encoder, the only cross-modal pair aligned after the control, with and without a contrastive loss.</a:t>
             </a:r>
             <a:endParaRPr lang="en-US" sz="1500" dirty="0"/>
           </a:p>
@@ -10529,7 +10618,7 @@
       </p:sp>
       <p:sp>
         <p:nvSpPr>
-          <p:cNvPr id="10" name="Shape 8"/>
+          <p:cNvPr id="10" name="Card 3"/>
           <p:cNvSpPr/>
           <p:nvPr/>
         </p:nvSpPr>
@@ -10556,7 +10645,7 @@
       </p:sp>
       <p:sp>
         <p:nvSpPr>
-          <p:cNvPr id="11" name="Text 9"/>
+          <p:cNvPr id="11" name="Card 3 title"/>
           <p:cNvSpPr txBox="1"/>
           <p:nvPr/>
         </p:nvSpPr>
@@ -10587,7 +10676,7 @@
                 <a:ea typeface="Calibri" pitchFamily="34" charset="-122"/>
                 <a:cs typeface="Calibri" pitchFamily="34" charset="-120"/>
               </a:rPr>
-              <a:t>One encoder per redundant family</a:t>
+              <a:t>Start with the pairs Stage 1 favors</a:t>
             </a:r>
             <a:endParaRPr lang="en-US" sz="1600" dirty="0"/>
           </a:p>
@@ -10595,14 +10684,14 @@
       </p:sp>
       <p:sp>
         <p:nvSpPr>
-          <p:cNvPr id="12" name="Text 10"/>
+          <p:cNvPr id="12" name="Card 3 body"/>
           <p:cNvSpPr txBox="1"/>
           <p:nvPr/>
         </p:nvSpPr>
         <p:spPr>
           <a:xfrm>
-            <a:off x="960120" y="4361688"/>
-            <a:ext cx="4722876" cy="1188720"/>
+            <a:off x="960120" y="4398264"/>
+            <a:ext cx="4722876" cy="1106424"/>
           </a:xfrm>
           <a:prstGeom prst="rect">
             <a:avLst/>
@@ -10626,7 +10715,7 @@
                 <a:ea typeface="Calibri" pitchFamily="34" charset="-122"/>
                 <a:cs typeface="Calibri" pitchFamily="34" charset="-120"/>
               </a:rPr>
-              <a:t>One ESM-2 model per experiment, with ProtBERT as a separate candidate. RNA-FM and RiNALMo are nearly redundant (CKA 0.809).</a:t>
+              <a:t>Stability: mRNA-FM or CaLM with ESM-2 150M or ProtBERT. GTEx: transcript and protein plus the DNA window, against the length baseline. One ESM-2 model per experiment.</a:t>
             </a:r>
             <a:endParaRPr lang="en-US" sz="1500" dirty="0"/>
           </a:p>
@@ -10634,7 +10723,7 @@
       </p:sp>
       <p:sp>
         <p:nvSpPr>
-          <p:cNvPr id="13" name="Shape 11"/>
+          <p:cNvPr id="13" name="Card 4"/>
           <p:cNvSpPr/>
           <p:nvPr/>
         </p:nvSpPr>
@@ -10661,7 +10750,7 @@
       </p:sp>
       <p:sp>
         <p:nvSpPr>
-          <p:cNvPr id="14" name="Text 12"/>
+          <p:cNvPr id="14" name="Card 4 title"/>
           <p:cNvSpPr txBox="1"/>
           <p:nvPr/>
         </p:nvSpPr>
@@ -10692,7 +10781,7 @@
                 <a:ea typeface="Calibri" pitchFamily="34" charset="-122"/>
                 <a:cs typeface="Calibri" pitchFamily="34" charset="-120"/>
               </a:rPr>
-              <a:t>First pairings</a:t>
+              <a:t>Report alignment beside every fusion gain</a:t>
             </a:r>
             <a:endParaRPr lang="en-US" sz="1600" dirty="0"/>
           </a:p>
@@ -10700,14 +10789,14 @@
       </p:sp>
       <p:sp>
         <p:nvSpPr>
-          <p:cNvPr id="15" name="Text 13"/>
+          <p:cNvPr id="15" name="Card 4 body"/>
           <p:cNvSpPr txBox="1"/>
           <p:nvPr/>
         </p:nvSpPr>
         <p:spPr>
           <a:xfrm>
-            <a:off x="6505956" y="4361688"/>
-            <a:ext cx="4722876" cy="1188720"/>
+            <a:off x="6505956" y="4398264"/>
+            <a:ext cx="4722876" cy="1106424"/>
           </a:xfrm>
           <a:prstGeom prst="rect">
             <a:avLst/>
@@ -10731,7 +10820,7 @@
                 <a:ea typeface="Calibri" pitchFamily="34" charset="-122"/>
                 <a:cs typeface="Calibri" pitchFamily="34" charset="-120"/>
               </a:rPr>
-              <a:t>Stability: mRNA-FM or CaLM with ESM-2 150M or ProtBERT, the consistent concatenation gains. GTEx: transcript and protein plus the DNA window, always against the length baseline.</a:t>
+              <a:t>CKA and Recall@1 before and after the composition control, next to each pair's gain. If Stage 1 predicts where fusion helps, that is the method.</a:t>
             </a:r>
             <a:endParaRPr lang="en-US" sz="1500" dirty="0"/>
           </a:p>
@@ -10739,7 +10828,7 @@
       </p:sp>
       <p:sp>
         <p:nvSpPr>
-          <p:cNvPr id="16" name="Text 14"/>
+          <p:cNvPr id="16" name="Bottom line"/>
           <p:cNvSpPr txBox="1"/>
           <p:nvPr/>
         </p:nvSpPr>
@@ -10770,7 +10859,7 @@
                 <a:ea typeface="Calibri" pitchFamily="34" charset="-122"/>
                 <a:cs typeface="Calibri" pitchFamily="34" charset="-120"/>
               </a:rPr>
-              <a:t>Alignment here: agreement on held-out examples after the composition control, reported separately from predictive complementarity.</a:t>
+              <a:t>Stage 2 runs no experiments; its decision is what sends the project straight into Stage 3.</a:t>
             </a:r>
             <a:endParaRPr lang="en-US" sz="1300" dirty="0"/>
           </a:p>
@@ -11195,7 +11284,7 @@
                 <a:ea typeface="Calibri" pitchFamily="34" charset="-122"/>
                 <a:cs typeface="Calibri" pitchFamily="34" charset="-120"/>
               </a:rPr>
-              <a:t>Does a per-pair alignment decision fit the lab's alignment study, or should one method cover all three modalities?</a:t>
+              <a:t>Does our definition, positional alignment from biology and representational alignment as a measurement, fit the lab's alignment study?</a:t>
             </a:r>
             <a:endParaRPr lang="en-US" sz="1400" dirty="0"/>
           </a:p>
@@ -11264,6 +11353,583 @@
               <a:t>Is CaLM's attention to AU-rich pentamers worth a follow-up with more sequences and permutations?</a:t>
             </a:r>
             <a:endParaRPr lang="en-US" sz="1400" dirty="0"/>
+          </a:p>
+        </p:txBody>
+      </p:sp>
+    </p:spTree>
+  </p:cSld>
+  <p:clrMapOvr>
+    <a:masterClrMapping/>
+  </p:clrMapOvr>
+</p:sld>
+</file>
+
+<file path=ppt/slides/slide15.xml><?xml version="1.0" encoding="utf-8"?>
+<p:sld xmlns:a="http://schemas.openxmlformats.org/drawingml/2006/main" xmlns:r="http://schemas.openxmlformats.org/officeDocument/2006/relationships" xmlns:p="http://schemas.openxmlformats.org/presentationml/2006/main">
+  <p:cSld name="Slide 13">
+    <p:bg>
+      <p:bgPr>
+        <a:solidFill>
+          <a:srgbClr val="FAFBF8"/>
+        </a:solidFill>
+      </p:bgPr>
+    </p:bg>
+    <p:spTree>
+      <p:nvGrpSpPr>
+        <p:cNvPr id="1" name=""/>
+        <p:cNvGrpSpPr/>
+        <p:nvPr/>
+      </p:nvGrpSpPr>
+      <p:grpSpPr>
+        <a:xfrm>
+          <a:off x="0" y="0"/>
+          <a:ext cx="0" cy="0"/>
+          <a:chOff x="0" y="0"/>
+          <a:chExt cx="0" cy="0"/>
+        </a:xfrm>
+      </p:grpSpPr>
+      <p:sp>
+        <p:nvSpPr>
+          <p:cNvPr id="2" name="Eyebrow"/>
+          <p:cNvSpPr txBox="1"/>
+          <p:nvPr/>
+        </p:nvSpPr>
+        <p:spPr>
+          <a:xfrm>
+            <a:off x="685800" y="457200"/>
+            <a:ext cx="10817352" cy="320040"/>
+          </a:xfrm>
+          <a:prstGeom prst="rect">
+            <a:avLst/>
+          </a:prstGeom>
+          <a:noFill/>
+          <a:ln/>
+        </p:spPr>
+        <p:txBody>
+          <a:bodyPr wrap="square" lIns="0" tIns="0" rIns="0" bIns="0" rtlCol="0" anchor="ctr"/>
+          <a:lstStyle/>
+          <a:p>
+            <a:pPr indent="0" marL="0">
+              <a:buNone/>
+            </a:pPr>
+            <a:r>
+              <a:rPr lang="en-US" sz="1300" b="1" spc="300" kern="0" dirty="0">
+                <a:solidFill>
+                  <a:srgbClr val="3E7A34"/>
+                </a:solidFill>
+                <a:latin typeface="Calibri" pitchFamily="34" charset="0"/>
+                <a:ea typeface="Calibri" pitchFamily="34" charset="-122"/>
+                <a:cs typeface="Calibri" pitchFamily="34" charset="-120"/>
+              </a:rPr>
+              <a:t>STAGE 2 · WHAT ALIGNMENT MEANS</a:t>
+            </a:r>
+            <a:endParaRPr lang="en-US" sz="1300" dirty="0"/>
+          </a:p>
+        </p:txBody>
+      </p:sp>
+      <p:sp>
+        <p:nvSpPr>
+          <p:cNvPr id="3" name="Title"/>
+          <p:cNvSpPr txBox="1"/>
+          <p:nvPr/>
+        </p:nvSpPr>
+        <p:spPr>
+          <a:xfrm>
+            <a:off x="685800" y="777240"/>
+            <a:ext cx="10817352" cy="685800"/>
+          </a:xfrm>
+          <a:prstGeom prst="rect">
+            <a:avLst/>
+          </a:prstGeom>
+          <a:noFill/>
+          <a:ln/>
+        </p:spPr>
+        <p:txBody>
+          <a:bodyPr wrap="square" lIns="0" tIns="0" rIns="0" bIns="0" rtlCol="0" anchor="ctr"/>
+          <a:lstStyle/>
+          <a:p>
+            <a:pPr indent="0" marL="0">
+              <a:buNone/>
+            </a:pPr>
+            <a:r>
+              <a:rPr lang="en-US" sz="3200" b="1" dirty="0">
+                <a:solidFill>
+                  <a:srgbClr val="1E2A20"/>
+                </a:solidFill>
+                <a:latin typeface="Cambria" pitchFamily="34" charset="0"/>
+                <a:ea typeface="Cambria" pitchFamily="34" charset="-122"/>
+                <a:cs typeface="Cambria" pitchFamily="34" charset="-120"/>
+              </a:rPr>
+              <a:t>Two kinds of alignment: one given, one measured</a:t>
+            </a:r>
+            <a:endParaRPr lang="en-US" sz="3200" dirty="0"/>
+          </a:p>
+        </p:txBody>
+      </p:sp>
+      <p:sp>
+        <p:nvSpPr>
+          <p:cNvPr id="4" name="Card 1"/>
+          <p:cNvSpPr/>
+          <p:nvPr/>
+        </p:nvSpPr>
+        <p:spPr>
+          <a:xfrm>
+            <a:off x="685800" y="1645920"/>
+            <a:ext cx="5271516" cy="3566160"/>
+          </a:xfrm>
+          <a:prstGeom prst="roundRect">
+            <a:avLst>
+              <a:gd name="adj" fmla="val 3902"/>
+            </a:avLst>
+          </a:prstGeom>
+          <a:solidFill>
+            <a:srgbClr val="EEF3EA"/>
+          </a:solidFill>
+          <a:ln w="12700">
+            <a:solidFill>
+              <a:srgbClr val="EEF3EA"/>
+            </a:solidFill>
+            <a:prstDash val="solid"/>
+          </a:ln>
+        </p:spPr>
+      </p:sp>
+      <p:sp>
+        <p:nvSpPr>
+          <p:cNvPr id="5" name="Card 1 title"/>
+          <p:cNvSpPr txBox="1"/>
+          <p:nvPr/>
+        </p:nvSpPr>
+        <p:spPr>
+          <a:xfrm>
+            <a:off x="960120" y="1810512"/>
+            <a:ext cx="4722876" cy="365760"/>
+          </a:xfrm>
+          <a:prstGeom prst="rect">
+            <a:avLst/>
+          </a:prstGeom>
+          <a:noFill/>
+          <a:ln/>
+        </p:spPr>
+        <p:txBody>
+          <a:bodyPr wrap="square" lIns="0" tIns="0" rIns="0" bIns="0" rtlCol="0" anchor="ctr"/>
+          <a:lstStyle/>
+          <a:p>
+            <a:pPr indent="0" marL="0">
+              <a:buNone/>
+            </a:pPr>
+            <a:r>
+              <a:rPr lang="en-US" sz="1600" b="1" dirty="0">
+                <a:solidFill>
+                  <a:srgbClr val="1E2A20"/>
+                </a:solidFill>
+                <a:latin typeface="Calibri" pitchFamily="34" charset="0"/>
+                <a:ea typeface="Calibri" pitchFamily="34" charset="-122"/>
+                <a:cs typeface="Calibri" pitchFamily="34" charset="-120"/>
+              </a:rPr>
+              <a:t>Positional alignment: given by biology</a:t>
+            </a:r>
+            <a:endParaRPr lang="en-US" sz="1600" dirty="0"/>
+          </a:p>
+        </p:txBody>
+      </p:sp>
+      <p:sp>
+        <p:nvSpPr>
+          <p:cNvPr id="6" name="Card 1 body"/>
+          <p:cNvSpPr txBox="1"/>
+          <p:nvPr/>
+        </p:nvSpPr>
+        <p:spPr>
+          <a:xfrm>
+            <a:off x="960120" y="2249424"/>
+            <a:ext cx="4722876" cy="2798064"/>
+          </a:xfrm>
+          <a:prstGeom prst="rect">
+            <a:avLst/>
+          </a:prstGeom>
+          <a:noFill/>
+          <a:ln/>
+        </p:spPr>
+        <p:txBody>
+          <a:bodyPr wrap="square" lIns="0" tIns="0" rIns="0" bIns="0" rtlCol="0" anchor="t"/>
+          <a:lstStyle/>
+          <a:p>
+            <a:pPr indent="0" marL="0">
+              <a:spcAft>
+                <a:spcPts val="700"/>
+              </a:spcAft>
+              <a:buNone/>
+            </a:pPr>
+            <a:r>
+              <a:rPr lang="en-US" sz="1400" dirty="0">
+                <a:solidFill>
+                  <a:srgbClr val="46524A"/>
+                </a:solidFill>
+                <a:latin typeface="Calibri" pitchFamily="34" charset="0"/>
+                <a:ea typeface="Calibri" pitchFamily="34" charset="-122"/>
+                <a:cs typeface="Calibri" pitchFamily="34" charset="-120"/>
+              </a:rPr>
+              <a:t>Step t in every input must mean the same place in the gene, like video frame t and audio window t. Coupled Mamba needs this.</a:t>
+            </a:r>
+            <a:endParaRPr lang="en-US" sz="1400" dirty="0"/>
+          </a:p>
+          <a:p>
+            <a:pPr indent="0" marL="0">
+              <a:spcAft>
+                <a:spcPts val="300"/>
+              </a:spcAft>
+              <a:buNone/>
+            </a:pPr>
+            <a:r>
+              <a:rPr lang="en-US" sz="1400" b="1" dirty="0">
+                <a:solidFill>
+                  <a:srgbClr val="1E2A20"/>
+                </a:solidFill>
+                <a:latin typeface="Calibri" pitchFamily="34" charset="0"/>
+                <a:ea typeface="Calibri" pitchFamily="34" charset="-122"/>
+                <a:cs typeface="Calibri" pitchFamily="34" charset="-120"/>
+              </a:rPr>
+              <a:t>Stability: </a:t>
+            </a:r>
+            <a:r>
+              <a:rPr lang="en-US" sz="1400" dirty="0">
+                <a:solidFill>
+                  <a:srgbClr val="46524A"/>
+                </a:solidFill>
+                <a:latin typeface="Calibri" pitchFamily="34" charset="0"/>
+                <a:ea typeface="Calibri" pitchFamily="34" charset="-122"/>
+                <a:cs typeface="Calibri" pitchFamily="34" charset="-120"/>
+              </a:rPr>
+              <a:t>each codon maps to one amino acid, so every stream can be resampled to one codon grid. For a 900-nt coding sequence:</a:t>
+            </a:r>
+            <a:endParaRPr lang="en-US" sz="1400" dirty="0"/>
+          </a:p>
+          <a:p>
+            <a:pPr marL="285750" indent="-285750">
+              <a:spcAft>
+                <a:spcPts val="200"/>
+              </a:spcAft>
+              <a:buSzPct val="100000"/>
+              <a:buChar char="•"/>
+            </a:pPr>
+            <a:r>
+              <a:rPr lang="en-US" sz="1400" dirty="0">
+                <a:solidFill>
+                  <a:srgbClr val="46524A"/>
+                </a:solidFill>
+                <a:latin typeface="Calibri" pitchFamily="34" charset="0"/>
+                <a:ea typeface="Calibri" pitchFamily="34" charset="-122"/>
+                <a:cs typeface="Calibri" pitchFamily="34" charset="-120"/>
+              </a:rPr>
+              <a:t>RNA-FM: 900 nucleotide tokens, averaged in threes</a:t>
+            </a:r>
+            <a:endParaRPr lang="en-US" sz="1400" dirty="0"/>
+          </a:p>
+          <a:p>
+            <a:pPr marL="285750" indent="-285750">
+              <a:spcAft>
+                <a:spcPts val="200"/>
+              </a:spcAft>
+              <a:buSzPct val="100000"/>
+              <a:buChar char="•"/>
+            </a:pPr>
+            <a:r>
+              <a:rPr lang="en-US" sz="1400" dirty="0">
+                <a:solidFill>
+                  <a:srgbClr val="46524A"/>
+                </a:solidFill>
+                <a:latin typeface="Calibri" pitchFamily="34" charset="0"/>
+                <a:ea typeface="Calibri" pitchFamily="34" charset="-122"/>
+                <a:cs typeface="Calibri" pitchFamily="34" charset="-120"/>
+              </a:rPr>
+              <a:t>NT 500M: 150 six-nucleotide tokens, each split in two</a:t>
+            </a:r>
+            <a:endParaRPr lang="en-US" sz="1400" dirty="0"/>
+          </a:p>
+          <a:p>
+            <a:pPr marL="285750" indent="-285750">
+              <a:spcAft>
+                <a:spcPts val="700"/>
+              </a:spcAft>
+              <a:buSzPct val="100000"/>
+              <a:buChar char="•"/>
+            </a:pPr>
+            <a:r>
+              <a:rPr lang="en-US" sz="1400" dirty="0">
+                <a:solidFill>
+                  <a:srgbClr val="46524A"/>
+                </a:solidFill>
+                <a:latin typeface="Calibri" pitchFamily="34" charset="0"/>
+                <a:ea typeface="Calibri" pitchFamily="34" charset="-122"/>
+                <a:cs typeface="Calibri" pitchFamily="34" charset="-120"/>
+              </a:rPr>
+              <a:t>CaLM (300 codons), ESM-2 (about 300 amino acids): already one per codon</a:t>
+            </a:r>
+            <a:endParaRPr lang="en-US" sz="1400" dirty="0"/>
+          </a:p>
+          <a:p>
+            <a:pPr indent="0" marL="0">
+              <a:buNone/>
+            </a:pPr>
+            <a:r>
+              <a:rPr lang="en-US" sz="1400" b="1" dirty="0">
+                <a:solidFill>
+                  <a:srgbClr val="1E2A20"/>
+                </a:solidFill>
+                <a:latin typeface="Calibri" pitchFamily="34" charset="0"/>
+                <a:ea typeface="Calibri" pitchFamily="34" charset="-122"/>
+                <a:cs typeface="Calibri" pitchFamily="34" charset="-120"/>
+              </a:rPr>
+              <a:t>GTEx: </a:t>
+            </a:r>
+            <a:r>
+              <a:rPr lang="en-US" sz="1400" dirty="0">
+                <a:solidFill>
+                  <a:srgbClr val="46524A"/>
+                </a:solidFill>
+                <a:latin typeface="Calibri" pitchFamily="34" charset="0"/>
+                <a:ea typeface="Calibri" pitchFamily="34" charset="-122"/>
+                <a:cs typeface="Calibri" pitchFamily="34" charset="-120"/>
+              </a:rPr>
+              <a:t>promoter DNA, transcript, and protein have no position-by-position match, so fusion uses cross-attention.</a:t>
+            </a:r>
+            <a:endParaRPr lang="en-US" sz="1400" dirty="0"/>
+          </a:p>
+        </p:txBody>
+      </p:sp>
+      <p:sp>
+        <p:nvSpPr>
+          <p:cNvPr id="7" name="Card 2"/>
+          <p:cNvSpPr/>
+          <p:nvPr/>
+        </p:nvSpPr>
+        <p:spPr>
+          <a:xfrm>
+            <a:off x="6231636" y="1645920"/>
+            <a:ext cx="5271516" cy="3566160"/>
+          </a:xfrm>
+          <a:prstGeom prst="roundRect">
+            <a:avLst>
+              <a:gd name="adj" fmla="val 3902"/>
+            </a:avLst>
+          </a:prstGeom>
+          <a:solidFill>
+            <a:srgbClr val="EEF3EA"/>
+          </a:solidFill>
+          <a:ln w="12700">
+            <a:solidFill>
+              <a:srgbClr val="EEF3EA"/>
+            </a:solidFill>
+            <a:prstDash val="solid"/>
+          </a:ln>
+        </p:spPr>
+      </p:sp>
+      <p:sp>
+        <p:nvSpPr>
+          <p:cNvPr id="8" name="Card 2 title"/>
+          <p:cNvSpPr txBox="1"/>
+          <p:nvPr/>
+        </p:nvSpPr>
+        <p:spPr>
+          <a:xfrm>
+            <a:off x="6505956" y="1810512"/>
+            <a:ext cx="4722876" cy="365760"/>
+          </a:xfrm>
+          <a:prstGeom prst="rect">
+            <a:avLst/>
+          </a:prstGeom>
+          <a:noFill/>
+          <a:ln/>
+        </p:spPr>
+        <p:txBody>
+          <a:bodyPr wrap="square" lIns="0" tIns="0" rIns="0" bIns="0" rtlCol="0" anchor="ctr"/>
+          <a:lstStyle/>
+          <a:p>
+            <a:pPr indent="0" marL="0">
+              <a:buNone/>
+            </a:pPr>
+            <a:r>
+              <a:rPr lang="en-US" sz="1600" b="1" dirty="0">
+                <a:solidFill>
+                  <a:srgbClr val="1E2A20"/>
+                </a:solidFill>
+                <a:latin typeface="Calibri" pitchFamily="34" charset="0"/>
+                <a:ea typeface="Calibri" pitchFamily="34" charset="-122"/>
+                <a:cs typeface="Calibri" pitchFamily="34" charset="-120"/>
+              </a:rPr>
+              <a:t>Representational alignment: measured</a:t>
+            </a:r>
+            <a:endParaRPr lang="en-US" sz="1600" dirty="0"/>
+          </a:p>
+        </p:txBody>
+      </p:sp>
+      <p:sp>
+        <p:nvSpPr>
+          <p:cNvPr id="9" name="Card 2 body"/>
+          <p:cNvSpPr txBox="1"/>
+          <p:nvPr/>
+        </p:nvSpPr>
+        <p:spPr>
+          <a:xfrm>
+            <a:off x="6505956" y="2249424"/>
+            <a:ext cx="4722876" cy="2798064"/>
+          </a:xfrm>
+          <a:prstGeom prst="rect">
+            <a:avLst/>
+          </a:prstGeom>
+          <a:noFill/>
+          <a:ln/>
+        </p:spPr>
+        <p:txBody>
+          <a:bodyPr wrap="square" lIns="0" tIns="0" rIns="0" bIns="0" rtlCol="0" anchor="t"/>
+          <a:lstStyle/>
+          <a:p>
+            <a:pPr indent="0" marL="0">
+              <a:spcAft>
+                <a:spcPts val="700"/>
+              </a:spcAft>
+              <a:buNone/>
+            </a:pPr>
+            <a:r>
+              <a:rPr lang="en-US" sz="1400" dirty="0">
+                <a:solidFill>
+                  <a:srgbClr val="46524A"/>
+                </a:solidFill>
+                <a:latin typeface="Calibri" pitchFamily="34" charset="0"/>
+                <a:ea typeface="Calibri" pitchFamily="34" charset="-122"/>
+                <a:cs typeface="Calibri" pitchFamily="34" charset="-120"/>
+              </a:rPr>
+              <a:t>Do two encoders see the same genes as similar? Stage 1 measured it with CKA, nearest neighbors, RSA, and CCA retrieval.</a:t>
+            </a:r>
+            <a:endParaRPr lang="en-US" sz="1400" dirty="0"/>
+          </a:p>
+          <a:p>
+            <a:pPr indent="0" marL="0">
+              <a:spcAft>
+                <a:spcPts val="700"/>
+              </a:spcAft>
+              <a:buNone/>
+            </a:pPr>
+            <a:r>
+              <a:rPr lang="en-US" sz="1400" b="1" dirty="0">
+                <a:solidFill>
+                  <a:srgbClr val="1E2A20"/>
+                </a:solidFill>
+                <a:latin typeface="Calibri" pitchFamily="34" charset="0"/>
+                <a:ea typeface="Calibri" pitchFamily="34" charset="-122"/>
+                <a:cs typeface="Calibri" pitchFamily="34" charset="-120"/>
+              </a:rPr>
+              <a:t>Mostly composition. </a:t>
+            </a:r>
+            <a:r>
+              <a:rPr lang="en-US" sz="1400" dirty="0">
+                <a:solidFill>
+                  <a:srgbClr val="46524A"/>
+                </a:solidFill>
+                <a:latin typeface="Calibri" pitchFamily="34" charset="0"/>
+                <a:ea typeface="Calibri" pitchFamily="34" charset="-122"/>
+                <a:cs typeface="Calibri" pitchFamily="34" charset="-120"/>
+              </a:rPr>
+              <a:t>Removing letter, codon, and amino-acid counts cuts CKA 52% to 90% for every pair with a DNA encoder.</a:t>
+            </a:r>
+            <a:endParaRPr lang="en-US" sz="1400" dirty="0"/>
+          </a:p>
+          <a:p>
+            <a:pPr indent="0" marL="0">
+              <a:spcAft>
+                <a:spcPts val="700"/>
+              </a:spcAft>
+              <a:buNone/>
+            </a:pPr>
+            <a:r>
+              <a:rPr lang="en-US" sz="1400" b="1" dirty="0">
+                <a:solidFill>
+                  <a:srgbClr val="1E2A20"/>
+                </a:solidFill>
+                <a:latin typeface="Calibri" pitchFamily="34" charset="0"/>
+                <a:ea typeface="Calibri" pitchFamily="34" charset="-122"/>
+                <a:cs typeface="Calibri" pitchFamily="34" charset="-120"/>
+              </a:rPr>
+              <a:t>Few pairs survive. </a:t>
+            </a:r>
+            <a:r>
+              <a:rPr lang="en-US" sz="1400" dirty="0">
+                <a:solidFill>
+                  <a:srgbClr val="46524A"/>
+                </a:solidFill>
+                <a:latin typeface="Calibri" pitchFamily="34" charset="0"/>
+                <a:ea typeface="Calibri" pitchFamily="34" charset="-122"/>
+                <a:cs typeface="Calibri" pitchFamily="34" charset="-120"/>
+              </a:rPr>
+              <a:t>ESM-2 models, RNA-FM with RiNALMo, and CaLM with protein, which still finds its protein partner 58% to 69% of the time (chance 0.3%).</a:t>
+            </a:r>
+            <a:endParaRPr lang="en-US" sz="1400" dirty="0"/>
+          </a:p>
+          <a:p>
+            <a:pPr indent="0" marL="0">
+              <a:buNone/>
+            </a:pPr>
+            <a:r>
+              <a:rPr lang="en-US" sz="1400" b="1" dirty="0">
+                <a:solidFill>
+                  <a:srgbClr val="1E2A20"/>
+                </a:solidFill>
+                <a:latin typeface="Calibri" pitchFamily="34" charset="0"/>
+                <a:ea typeface="Calibri" pitchFamily="34" charset="-122"/>
+                <a:cs typeface="Calibri" pitchFamily="34" charset="-120"/>
+              </a:rPr>
+              <a:t>Not usefulness. </a:t>
+            </a:r>
+            <a:r>
+              <a:rPr lang="en-US" sz="1400" dirty="0">
+                <a:solidFill>
+                  <a:srgbClr val="46524A"/>
+                </a:solidFill>
+                <a:latin typeface="Calibri" pitchFamily="34" charset="0"/>
+                <a:ea typeface="Calibri" pitchFamily="34" charset="-122"/>
+                <a:cs typeface="Calibri" pitchFamily="34" charset="-120"/>
+              </a:rPr>
+              <a:t>Alignment never tracks prediction error (66 pairs, both datasets), and some of the best pairings barely align.</a:t>
+            </a:r>
+            <a:endParaRPr lang="en-US" sz="1400" dirty="0"/>
+          </a:p>
+        </p:txBody>
+      </p:sp>
+      <p:sp>
+        <p:nvSpPr>
+          <p:cNvPr id="10" name="Definition"/>
+          <p:cNvSpPr txBox="1"/>
+          <p:nvPr/>
+        </p:nvSpPr>
+        <p:spPr>
+          <a:xfrm>
+            <a:off x="685800" y="5394960"/>
+            <a:ext cx="10817352" cy="457200"/>
+          </a:xfrm>
+          <a:prstGeom prst="rect">
+            <a:avLst/>
+          </a:prstGeom>
+          <a:noFill/>
+          <a:ln/>
+        </p:spPr>
+        <p:txBody>
+          <a:bodyPr wrap="square" lIns="0" tIns="0" rIns="0" bIns="0" rtlCol="0" anchor="ctr"/>
+          <a:lstStyle/>
+          <a:p>
+            <a:pPr indent="0" marL="0">
+              <a:buNone/>
+            </a:pPr>
+            <a:r>
+              <a:rPr lang="en-US" sz="1300" i="1" dirty="0">
+                <a:solidFill>
+                  <a:srgbClr val="46524A"/>
+                </a:solidFill>
+                <a:latin typeface="Calibri" pitchFamily="34" charset="0"/>
+                <a:ea typeface="Calibri" pitchFamily="34" charset="-122"/>
+                <a:cs typeface="Calibri" pitchFamily="34" charset="-120"/>
+              </a:rPr>
+              <a:t>For this project, two encoders are aligned to the extent that their representations agree on held-out sequences after the composition control: a measurement we report, not a goal we train toward.</a:t>
+            </a:r>
+            <a:endParaRPr lang="en-US" sz="1300" dirty="0"/>
           </a:p>
         </p:txBody>
       </p:sp>

</xml_diff>